<commit_message>
Final delivery: unified member info (Zhao Hao, Zhang Luxi), presenter badge on cover slide, README consistency fixes
- Unify members to 赵浩（U202541916）、张璐玺（U202541915）across paper cover, PPT slide 1, script and README
- Add presenter info bar (汇报人：张璐玺) to PPT cover slide
- README: 11 pages -> 10 pages; replace inaccurate vector-typesetting wording; remove outdated helper script
</commit_message>
<xml_diff>
--- a/presentation/probability-statistics-course-presentation.pptx
+++ b/presentation/probability-statistics-course-presentation.pptx
@@ -1819,7 +1819,7 @@
                 <a:ea typeface="微软雅黑" pitchFamily="34" charset="-122"/>
                 <a:cs typeface="微软雅黑" pitchFamily="34" charset="-120"/>
               </a:rPr>
-              <a:t>成员：赵浩（U202541916）、章轩睿（U202541911）</a:t>
+              <a:t>成员：赵浩（U202541916）、张璐玺（U202541915）</a:t>
             </a:r>
             <a:endParaRPr lang="en-US" sz="1800" dirty="0"/>
           </a:p>
@@ -1861,6 +1861,114 @@
               <a:t>日期：2026年9月26日</a:t>
             </a:r>
             <a:endParaRPr lang="en-US" sz="1600" dirty="0"/>
+          </a:p>
+        </p:txBody>
+      </p:sp>
+      <p:sp>
+        <p:nvSpPr>
+          <p:cNvPr id="7" name="Rectangle 6"/>
+          <p:cNvSpPr/>
+          <p:nvPr/>
+        </p:nvSpPr>
+        <p:spPr>
+          <a:xfrm>
+            <a:off x="5364480" y="5650992"/>
+            <a:ext cx="1463040" cy="32004"/>
+          </a:xfrm>
+          <a:prstGeom prst="rect">
+            <a:avLst/>
+          </a:prstGeom>
+          <a:solidFill>
+            <a:srgbClr val="B9C6D6"/>
+          </a:solidFill>
+          <a:ln>
+            <a:noFill/>
+          </a:ln>
+          <a:effectLst/>
+        </p:spPr>
+        <p:style>
+          <a:lnRef idx="1">
+            <a:schemeClr val="accent1"/>
+          </a:lnRef>
+          <a:fillRef idx="3">
+            <a:schemeClr val="accent1"/>
+          </a:fillRef>
+          <a:effectRef idx="2">
+            <a:schemeClr val="accent1"/>
+          </a:effectRef>
+          <a:fontRef idx="minor">
+            <a:schemeClr val="lt1"/>
+          </a:fontRef>
+        </p:style>
+        <p:txBody>
+          <a:bodyPr rtlCol="0" anchor="ctr"/>
+          <a:lstStyle/>
+          <a:p/>
+        </p:txBody>
+      </p:sp>
+      <p:sp>
+        <p:nvSpPr>
+          <p:cNvPr id="8" name="Rounded Rectangle 7"/>
+          <p:cNvSpPr/>
+          <p:nvPr/>
+        </p:nvSpPr>
+        <p:spPr>
+          <a:xfrm>
+            <a:off x="4130040" y="5870448"/>
+            <a:ext cx="3931920" cy="603504"/>
+          </a:xfrm>
+          <a:prstGeom prst="roundRect">
+            <a:avLst>
+              <a:gd name="adj" fmla="val 35000"/>
+            </a:avLst>
+          </a:prstGeom>
+          <a:solidFill>
+            <a:srgbClr val="F1F4F8"/>
+          </a:solidFill>
+          <a:ln w="9525">
+            <a:solidFill>
+              <a:srgbClr val="D3DCE7"/>
+            </a:solidFill>
+          </a:ln>
+          <a:effectLst/>
+        </p:spPr>
+        <p:style>
+          <a:lnRef idx="1">
+            <a:schemeClr val="accent1"/>
+          </a:lnRef>
+          <a:fillRef idx="3">
+            <a:schemeClr val="accent1"/>
+          </a:fillRef>
+          <a:effectRef idx="2">
+            <a:schemeClr val="accent1"/>
+          </a:effectRef>
+          <a:fontRef idx="minor">
+            <a:schemeClr val="lt1"/>
+          </a:fontRef>
+        </p:style>
+        <p:txBody>
+          <a:bodyPr rtlCol="0" anchor="ctr" wrap="none" tIns="0" bIns="0" lIns="109728" rIns="109728"/>
+          <a:lstStyle/>
+          <a:p>
+            <a:pPr algn="ctr"/>
+            <a:r>
+              <a:rPr sz="1300" b="0">
+                <a:solidFill>
+                  <a:srgbClr val="6B7686"/>
+                </a:solidFill>
+                <a:latin typeface="微软雅黑"/>
+              </a:rPr>
+              <a:t>汇报人：</a:t>
+            </a:r>
+            <a:r>
+              <a:rPr sz="1700" b="1">
+                <a:solidFill>
+                  <a:srgbClr val="1E3A5F"/>
+                </a:solidFill>
+                <a:latin typeface="微软雅黑"/>
+              </a:rPr>
+              <a:t>张璐玺</a:t>
+            </a:r>
           </a:p>
         </p:txBody>
       </p:sp>

</xml_diff>

<commit_message>
Final three-member delivery: cover author list, PPT cover row, README privacy cleanup
- Paper cover: authors now 赵浩、张璐玺、章轩睿 with IDs U202541916 / U202541915 / U202541911
  (body paragraphs, tables, figures and all statistics verified unchanged); PDF re-exported.
- PPT slide 1: three members listed one per line, presenter 张璐玺 and date 2026年9月26日
  in a balanced members | presenter | date row; title stays the visual centre; presenter
  type size reduced so it no longer outranks the member information; PDF re-exported (10 pages).
- presentation_script.md: header lists all three members; opening line now credits
  赵浩、章轩睿 as co-authors, keeping the single-presenter first-person voice (~5 min).
- README.md: personal information removed entirely (no names, IDs, authors, members,
  presenter or dates); restructured as project introduction + reproduction guide.
- .gitignore: ignore the local .workbuddy/ workspace folder.
</commit_message>
<xml_diff>
--- a/presentation/probability-statistics-course-presentation.pptx
+++ b/presentation/probability-statistics-course-presentation.pptx
@@ -3280,8 +3280,8 @@
         </p:nvSpPr>
         <p:spPr>
           <a:xfrm>
-            <a:off x="2138650" y="4536369"/>
-            <a:ext cx="5074920" cy="592470"/>
+            <a:off x="2138650" y="4462431"/>
+            <a:ext cx="2100000" cy="800100"/>
           </a:xfrm>
           <a:prstGeom prst="rect">
             <a:avLst/>
@@ -3314,7 +3314,7 @@
                 </a:solidFill>
                 <a:latin typeface="微软雅黑"/>
               </a:rPr>
-              <a:t>赵浩（U202541916）　</a:t>
+              <a:t>赵浩（U202541916）</a:t>
             </a:r>
             <a:endParaRPr lang="en-US" sz="1400" b="0" dirty="0">
               <a:solidFill>
@@ -3335,6 +3335,18 @@
               <a:t>张璐玺（U202541915）</a:t>
             </a:r>
           </a:p>
+          <a:p>
+            <a:pPr algn="l"/>
+            <a:r>
+              <a:rPr sz="1102" b="0" dirty="0">
+                <a:solidFill>
+                  <a:srgbClr val="14263C"/>
+                </a:solidFill>
+                <a:latin typeface="微软雅黑"/>
+              </a:rPr>
+              <a:t>章轩睿（U202541911）</a:t>
+            </a:r>
+          </a:p>
         </p:txBody>
       </p:sp>
       <p:sp>
@@ -3345,7 +3357,7 @@
         </p:nvSpPr>
         <p:spPr>
           <a:xfrm>
-            <a:off x="6201140" y="4590288"/>
+            <a:off x="5098697" y="4620165"/>
             <a:ext cx="10972" cy="484632"/>
           </a:xfrm>
           <a:prstGeom prst="rect">
@@ -3389,8 +3401,8 @@
         </p:nvSpPr>
         <p:spPr>
           <a:xfrm>
-            <a:off x="7608764" y="4428141"/>
-            <a:ext cx="1874519" cy="868680"/>
+            <a:off x="6120583" y="4428141"/>
+            <a:ext cx="950000" cy="868680"/>
           </a:xfrm>
           <a:prstGeom prst="rect">
             <a:avLst/>
@@ -3426,7 +3438,7 @@
           <a:p>
             <a:pPr algn="l"/>
             <a:r>
-              <a:rPr sz="1700" b="1" dirty="0" err="1">
+              <a:rPr sz="1102" b="1" dirty="0" err="1">
                 <a:solidFill>
                   <a:srgbClr val="1B3A6B"/>
                 </a:solidFill>
@@ -3445,13 +3457,66 @@
       </p:sp>
       <p:sp>
         <p:nvSpPr>
+          <p:cNvPr id="9" name="TextBox 10"/>
+          <p:cNvSpPr txBox="1"/>
+          <p:nvPr/>
+        </p:nvSpPr>
+        <p:spPr>
+          <a:xfrm>
+            <a:off x="8790110" y="4428141"/>
+            <a:ext cx="1300000" cy="868680"/>
+          </a:xfrm>
+          <a:prstGeom prst="rect">
+            <a:avLst/>
+          </a:prstGeom>
+          <a:noFill/>
+        </p:spPr>
+        <p:txBody>
+          <a:bodyPr wrap="square" lIns="0" tIns="0" rIns="0" bIns="0" anchor="ctr">
+            <a:spAutoFit/>
+          </a:bodyPr>
+          <a:lstStyle/>
+          <a:p>
+            <a:pPr algn="l"/>
+            <a:r>
+              <a:rPr sz="826" b="0" dirty="0" err="1">
+                <a:solidFill>
+                  <a:srgbClr val="6E7A8A"/>
+                </a:solidFill>
+                <a:latin typeface="微软雅黑"/>
+              </a:rPr>
+              <a:t>日　期</a:t>
+            </a:r>
+          </a:p>
+          <a:p>
+            <a:pPr algn="l"/>
+            <a:r>
+              <a:rPr sz="1102" b="0" dirty="0" err="1">
+                <a:solidFill>
+                  <a:srgbClr val="14263C"/>
+                </a:solidFill>
+                <a:latin typeface="微软雅黑"/>
+              </a:rPr>
+              <a:t>2026年9月26日</a:t>
+            </a:r>
+            <a:endParaRPr sz="1700" b="1" dirty="0">
+              <a:solidFill>
+                <a:srgbClr val="1B3A6B"/>
+              </a:solidFill>
+              <a:latin typeface="微软雅黑"/>
+            </a:endParaRPr>
+          </a:p>
+        </p:txBody>
+      </p:sp>
+      <p:sp>
+        <p:nvSpPr>
           <p:cNvPr id="10" name="Rectangle 9"/>
           <p:cNvSpPr/>
           <p:nvPr/>
         </p:nvSpPr>
         <p:spPr>
           <a:xfrm>
-            <a:off x="8306089" y="4590288"/>
+            <a:off x="7768224" y="4620165"/>
             <a:ext cx="10972" cy="484632"/>
           </a:xfrm>
           <a:prstGeom prst="rect">

</xml_diff>